<commit_message>
docs: update architecture diagram
</commit_message>
<xml_diff>
--- a/docs/CleanArchitecture-Execution-Flow.pptx
+++ b/docs/CleanArchitecture-Execution-Flow.pptx
@@ -8124,7 +8124,7 @@
         <p:spPr>
           <a:xfrm>
             <a:off x="76200" y="76200"/>
-            <a:ext cx="12039600" cy="1104900"/>
+            <a:ext cx="12039600" cy="1163876"/>
           </a:xfrm>
           <a:prstGeom prst="roundRect">
             <a:avLst>
@@ -8163,8 +8163,8 @@
         </p:nvSpPr>
         <p:spPr>
           <a:xfrm>
-            <a:off x="133350" y="133349"/>
-            <a:ext cx="1645920" cy="982823"/>
+            <a:off x="133350" y="133348"/>
+            <a:ext cx="1645920" cy="1060704"/>
           </a:xfrm>
           <a:prstGeom prst="roundRect">
             <a:avLst>
@@ -8290,8 +8290,8 @@
         </p:nvSpPr>
         <p:spPr>
           <a:xfrm>
-            <a:off x="76200" y="1249680"/>
-            <a:ext cx="12039600" cy="779145"/>
+            <a:off x="76200" y="1316197"/>
+            <a:ext cx="12039600" cy="712628"/>
           </a:xfrm>
           <a:prstGeom prst="roundRect">
             <a:avLst>
@@ -8330,8 +8330,8 @@
         </p:nvSpPr>
         <p:spPr>
           <a:xfrm>
-            <a:off x="133350" y="1320085"/>
-            <a:ext cx="1645920" cy="640080"/>
+            <a:off x="133350" y="1376072"/>
+            <a:ext cx="1645920" cy="594360"/>
           </a:xfrm>
           <a:prstGeom prst="roundRect">
             <a:avLst>
@@ -9203,8 +9203,8 @@
         </p:nvSpPr>
         <p:spPr>
           <a:xfrm>
-            <a:off x="2388870" y="184461"/>
-            <a:ext cx="2468880" cy="285750"/>
+            <a:off x="2388870" y="147895"/>
+            <a:ext cx="2468880" cy="365760"/>
           </a:xfrm>
           <a:prstGeom prst="roundRect">
             <a:avLst>
@@ -9274,7 +9274,7 @@
         <p:spPr>
           <a:xfrm>
             <a:off x="2388870" y="706694"/>
-            <a:ext cx="2468880" cy="304800"/>
+            <a:ext cx="2468880" cy="365760"/>
           </a:xfrm>
           <a:prstGeom prst="roundRect">
             <a:avLst>
@@ -9304,7 +9304,7 @@
         </p:style>
         <p:txBody>
           <a:bodyPr wrap="square" lIns="76200" tIns="47625" rIns="76200" bIns="47625" anchor="ctr">
-            <a:normAutofit fontScale="92500" lnSpcReduction="10000"/>
+            <a:normAutofit/>
           </a:bodyPr>
           <a:lstStyle/>
           <a:p>
@@ -9348,8 +9348,8 @@
         </p:nvSpPr>
         <p:spPr>
           <a:xfrm>
-            <a:off x="5480475" y="174936"/>
-            <a:ext cx="2468880" cy="304800"/>
+            <a:off x="5480475" y="147895"/>
+            <a:ext cx="2468880" cy="365760"/>
           </a:xfrm>
           <a:prstGeom prst="roundRect">
             <a:avLst>
@@ -9419,7 +9419,7 @@
         <p:spPr>
           <a:xfrm>
             <a:off x="5480475" y="706694"/>
-            <a:ext cx="2468880" cy="304800"/>
+            <a:ext cx="2468880" cy="365760"/>
           </a:xfrm>
           <a:prstGeom prst="roundRect">
             <a:avLst>
@@ -9449,7 +9449,7 @@
         </p:style>
         <p:txBody>
           <a:bodyPr wrap="square" lIns="76200" tIns="47625" rIns="76200" bIns="47625" anchor="ctr">
-            <a:normAutofit lnSpcReduction="10000"/>
+            <a:normAutofit/>
           </a:bodyPr>
           <a:lstStyle/>
           <a:p>
@@ -9493,8 +9493,8 @@
         </p:nvSpPr>
         <p:spPr>
           <a:xfrm>
-            <a:off x="8814161" y="174936"/>
-            <a:ext cx="2468880" cy="304800"/>
+            <a:off x="8814161" y="147895"/>
+            <a:ext cx="2468880" cy="365760"/>
           </a:xfrm>
           <a:prstGeom prst="roundRect">
             <a:avLst>
@@ -9564,7 +9564,7 @@
         <p:spPr>
           <a:xfrm>
             <a:off x="8814161" y="706694"/>
-            <a:ext cx="2468880" cy="304800"/>
+            <a:ext cx="2468880" cy="365760"/>
           </a:xfrm>
           <a:prstGeom prst="roundRect">
             <a:avLst>
@@ -9594,7 +9594,7 @@
         </p:style>
         <p:txBody>
           <a:bodyPr wrap="square" lIns="76200" tIns="47625" rIns="76200" bIns="47625" anchor="ctr">
-            <a:normAutofit lnSpcReduction="10000"/>
+            <a:normAutofit/>
           </a:bodyPr>
           <a:lstStyle/>
           <a:p>
@@ -9638,7 +9638,7 @@
         </p:nvSpPr>
         <p:spPr>
           <a:xfrm>
-            <a:off x="7557428" y="1400174"/>
+            <a:off x="7557428" y="1459150"/>
             <a:ext cx="2035045" cy="361950"/>
           </a:xfrm>
           <a:prstGeom prst="roundRect">
@@ -9721,7 +9721,7 @@
         </p:nvSpPr>
         <p:spPr>
           <a:xfrm>
-            <a:off x="9704750" y="1404938"/>
+            <a:off x="9704750" y="1459150"/>
             <a:ext cx="2103118" cy="361950"/>
           </a:xfrm>
           <a:prstGeom prst="roundRect">
@@ -9915,7 +9915,7 @@
         </p:nvSpPr>
         <p:spPr>
           <a:xfrm>
-            <a:off x="7280542" y="2219324"/>
+            <a:off x="7317866" y="2219324"/>
             <a:ext cx="3074668" cy="590549"/>
           </a:xfrm>
           <a:prstGeom prst="roundRect">
@@ -9923,7 +9923,7 @@
               <a:gd name="adj" fmla="val 14000"/>
             </a:avLst>
           </a:prstGeom>
-          <a:ln/>
+          <a:ln w="19050"/>
         </p:spPr>
         <p:style>
           <a:lnRef idx="2">
@@ -10803,8 +10803,8 @@
         </p:nvCxnSpPr>
         <p:spPr>
           <a:xfrm>
-            <a:off x="3623310" y="470211"/>
-            <a:ext cx="0" cy="236483"/>
+            <a:off x="3623310" y="513655"/>
+            <a:ext cx="0" cy="193039"/>
           </a:xfrm>
           <a:prstGeom prst="straightConnector1">
             <a:avLst/>
@@ -10841,8 +10841,8 @@
         </p:nvCxnSpPr>
         <p:spPr>
           <a:xfrm>
-            <a:off x="6714915" y="479736"/>
-            <a:ext cx="0" cy="226958"/>
+            <a:off x="6714915" y="513655"/>
+            <a:ext cx="0" cy="193039"/>
           </a:xfrm>
           <a:prstGeom prst="straightConnector1">
             <a:avLst/>
@@ -10879,8 +10879,8 @@
         </p:nvCxnSpPr>
         <p:spPr>
           <a:xfrm>
-            <a:off x="10048601" y="479736"/>
-            <a:ext cx="0" cy="226958"/>
+            <a:off x="10048601" y="513655"/>
+            <a:ext cx="0" cy="193039"/>
           </a:xfrm>
           <a:prstGeom prst="straightConnector1">
             <a:avLst/>
@@ -10918,7 +10918,7 @@
         <p:spPr>
           <a:xfrm flipH="1">
             <a:off x="6947126" y="2514599"/>
-            <a:ext cx="333416" cy="1"/>
+            <a:ext cx="370740" cy="1"/>
           </a:xfrm>
           <a:prstGeom prst="straightConnector1">
             <a:avLst/>
@@ -11212,8 +11212,8 @@
         </p:nvCxnSpPr>
         <p:spPr>
           <a:xfrm>
-            <a:off x="10756309" y="1766888"/>
-            <a:ext cx="1" cy="3376612"/>
+            <a:off x="10756309" y="1821100"/>
+            <a:ext cx="1" cy="3322400"/>
           </a:xfrm>
           <a:prstGeom prst="straightConnector1">
             <a:avLst/>
@@ -11412,8 +11412,8 @@
         </p:nvCxnSpPr>
         <p:spPr>
           <a:xfrm>
-            <a:off x="4497501" y="1181100"/>
-            <a:ext cx="0" cy="1038225"/>
+            <a:off x="4497501" y="1248243"/>
+            <a:ext cx="0" cy="971082"/>
           </a:xfrm>
           <a:prstGeom prst="straightConnector1">
             <a:avLst/>
@@ -11466,7 +11466,7 @@
         </p:blipFill>
         <p:spPr>
           <a:xfrm>
-            <a:off x="2003016" y="167316"/>
+            <a:off x="2003016" y="168833"/>
             <a:ext cx="323884" cy="323884"/>
           </a:xfrm>
           <a:prstGeom prst="rect">
@@ -11502,7 +11502,7 @@
         </p:blipFill>
         <p:spPr>
           <a:xfrm>
-            <a:off x="5116682" y="167316"/>
+            <a:off x="5116682" y="170755"/>
             <a:ext cx="320040" cy="320040"/>
           </a:xfrm>
           <a:prstGeom prst="rect">
@@ -11538,7 +11538,7 @@
         </p:blipFill>
         <p:spPr>
           <a:xfrm>
-            <a:off x="8434787" y="167316"/>
+            <a:off x="8434787" y="170755"/>
             <a:ext cx="320040" cy="320040"/>
           </a:xfrm>
           <a:prstGeom prst="rect">
@@ -12112,7 +12112,7 @@
         </p:blipFill>
         <p:spPr>
           <a:xfrm>
-            <a:off x="9717429" y="1445806"/>
+            <a:off x="9717429" y="1502965"/>
             <a:ext cx="274320" cy="274320"/>
           </a:xfrm>
           <a:prstGeom prst="rect">
@@ -12136,7 +12136,7 @@
         </p:nvCxnSpPr>
         <p:spPr>
           <a:xfrm>
-            <a:off x="142681" y="1182926"/>
+            <a:off x="142681" y="1238912"/>
             <a:ext cx="11887200" cy="0"/>
           </a:xfrm>
           <a:prstGeom prst="line">
@@ -12176,7 +12176,7 @@
         </p:nvSpPr>
         <p:spPr>
           <a:xfrm>
-            <a:off x="10640300" y="1073759"/>
+            <a:off x="10640300" y="1129745"/>
             <a:ext cx="232017" cy="274320"/>
           </a:xfrm>
           <a:prstGeom prst="downArrow">
@@ -12235,7 +12235,7 @@
         </p:nvSpPr>
         <p:spPr>
           <a:xfrm>
-            <a:off x="8458941" y="1073759"/>
+            <a:off x="8458941" y="1129745"/>
             <a:ext cx="232017" cy="274320"/>
           </a:xfrm>
           <a:prstGeom prst="downArrow">
@@ -12297,8 +12297,8 @@
         </p:nvCxnSpPr>
         <p:spPr>
           <a:xfrm>
-            <a:off x="8574951" y="1762124"/>
-            <a:ext cx="0" cy="314326"/>
+            <a:off x="8574951" y="1821100"/>
+            <a:ext cx="0" cy="255350"/>
           </a:xfrm>
           <a:prstGeom prst="straightConnector1">
             <a:avLst/>
@@ -12351,7 +12351,7 @@
         </p:blipFill>
         <p:spPr>
           <a:xfrm>
-            <a:off x="7600305" y="1385798"/>
+            <a:off x="7600305" y="1457245"/>
             <a:ext cx="365760" cy="365760"/>
           </a:xfrm>
           <a:prstGeom prst="rect">

</xml_diff>

<commit_message>
refactor(exceptions): harden exception metadata and cancellation handling
</commit_message>
<xml_diff>
--- a/docs/CleanArchitecture-Execution-Flow.pptx
+++ b/docs/CleanArchitecture-Execution-Flow.pptx
@@ -9665,7 +9665,7 @@
         </p:nvSpPr>
         <p:spPr>
           <a:xfrm>
-            <a:off x="4912081" y="1457988"/>
+            <a:off x="4912081" y="1492277"/>
             <a:ext cx="2035045" cy="361950"/>
           </a:xfrm>
           <a:prstGeom prst="roundRect">
@@ -9748,7 +9748,7 @@
         </p:nvSpPr>
         <p:spPr>
           <a:xfrm>
-            <a:off x="9704750" y="1459150"/>
+            <a:off x="9704750" y="1492277"/>
             <a:ext cx="2103118" cy="361950"/>
           </a:xfrm>
           <a:prstGeom prst="roundRect">
@@ -11311,8 +11311,8 @@
         </p:nvCxnSpPr>
         <p:spPr>
           <a:xfrm>
-            <a:off x="10756309" y="1821100"/>
-            <a:ext cx="1" cy="3322400"/>
+            <a:off x="10756309" y="1854227"/>
+            <a:ext cx="1" cy="3289273"/>
           </a:xfrm>
           <a:prstGeom prst="straightConnector1">
             <a:avLst/>
@@ -12211,7 +12211,7 @@
         </p:blipFill>
         <p:spPr>
           <a:xfrm>
-            <a:off x="9717429" y="1502965"/>
+            <a:off x="9717429" y="1536092"/>
             <a:ext cx="274320" cy="274320"/>
           </a:xfrm>
           <a:prstGeom prst="rect">
@@ -12289,7 +12289,7 @@
         </p:blipFill>
         <p:spPr>
           <a:xfrm>
-            <a:off x="4954958" y="1456083"/>
+            <a:off x="4954958" y="1490372"/>
             <a:ext cx="365760" cy="365760"/>
           </a:xfrm>
           <a:prstGeom prst="rect">
@@ -12315,7 +12315,7 @@
         <p:spPr>
           <a:xfrm>
             <a:off x="5929604" y="1246453"/>
-            <a:ext cx="0" cy="211535"/>
+            <a:ext cx="0" cy="245824"/>
           </a:xfrm>
           <a:prstGeom prst="straightConnector1">
             <a:avLst/>
@@ -12358,7 +12358,7 @@
         <p:spPr>
           <a:xfrm>
             <a:off x="10756309" y="1238912"/>
-            <a:ext cx="0" cy="220238"/>
+            <a:ext cx="0" cy="253365"/>
           </a:xfrm>
           <a:prstGeom prst="straightConnector1">
             <a:avLst/>
@@ -12400,8 +12400,8 @@
         </p:nvCxnSpPr>
         <p:spPr>
           <a:xfrm>
-            <a:off x="5929604" y="1819938"/>
-            <a:ext cx="0" cy="399386"/>
+            <a:off x="5929604" y="1854227"/>
+            <a:ext cx="0" cy="365097"/>
           </a:xfrm>
           <a:prstGeom prst="straightConnector1">
             <a:avLst/>

</xml_diff>